<commit_message>
feat(academia): nueva seccion de cursos Power BI con 4 tiers + 12 materiales
</commit_message>
<xml_diff>
--- a/scorecard-General/PAGINA-2BI/academia/materiales/02_Express_Presentacion_Comercial.pptx
+++ b/scorecard-General/PAGINA-2BI/academia/materiales/02_Express_Presentacion_Comercial.pptx
@@ -6497,7 +6497,7 @@
                 <a:ea typeface="Calibri" pitchFamily="34" charset="-122"/>
                 <a:cs typeface="Calibri" pitchFamily="34" charset="-120"/>
               </a:rPr>
-              <a:t>✗  Necesitas RLS, Pipelines, Fabric (Estándar/Premium).</a:t>
+              <a:t>✗  Necesitas RLS, Pipelines, Power BI Premium (Estándar/Premium).</a:t>
             </a:r>
             <a:endParaRPr lang="en-US" sz="1200" dirty="0"/>
           </a:p>
@@ -11494,7 +11494,7 @@
                 <a:ea typeface="Calibri" pitchFamily="34" charset="-122"/>
                 <a:cs typeface="Calibri" pitchFamily="34" charset="-120"/>
               </a:rPr>
-              <a:t>★  Microsoft Fabric, Direct Lake y Semantic Link.</a:t>
+              <a:t>★  Power BI Premium, Premium Capacity y Semantic Link.</a:t>
             </a:r>
             <a:endParaRPr lang="en-US" sz="1300" dirty="0"/>
           </a:p>
@@ -11533,7 +11533,7 @@
                 <a:ea typeface="Calibri" pitchFamily="34" charset="-122"/>
                 <a:cs typeface="Calibri" pitchFamily="34" charset="-120"/>
               </a:rPr>
-              <a:t>★  Python (sempy, pandas, scikit-learn) y AI agents.</a:t>
+              <a:t>★  Python (DAX Studio, pandas, Tabular Editor) y AI agents.</a:t>
             </a:r>
             <a:endParaRPr lang="en-US" sz="1300" dirty="0"/>
           </a:p>
@@ -11572,7 +11572,7 @@
                 <a:ea typeface="Calibri" pitchFamily="34" charset="-122"/>
                 <a:cs typeface="Calibri" pitchFamily="34" charset="-120"/>
               </a:rPr>
-              <a:t>★  n8n, Anthropic Claude, orquestación de agentes.</a:t>
+              <a:t>★  Power BI Subscriptions, Smart Narrative, orquestación de agentes.</a:t>
             </a:r>
             <a:endParaRPr lang="en-US" sz="1300" dirty="0"/>
           </a:p>

</xml_diff>